<commit_message>
Adiciona roteiro de apresentacao e demo ao vivo para sala de aula
- docs/demo_sala_aula.ipynb: notebook autocontido que ranqueia uma
  pergunta real do conjunto de teste por TF-IDF, cosseno sobre
  BERTimbau congelado e Cross-Encoder treinado, usando so caches e
  checkpoints ja existentes (sem retreinar nada, cada celula roda em
  menos de 1s). Testado ponta a ponta.
- docs/Roteiro_Apresentacao_AgroSele.docx: roteiro slide a slide com
  tempo sugerido, fala de apoio, pontos de corte se faltar tempo,
  integracao da demo ao vivo e FAQ de perguntas esperadas da banca
- Slide novo "Demonstracao ao Vivo" em Apresentacao_AgroSele.pptx
  (12 slides), e correcao de terminologia no slide 5 (Cross-Encoder:
  self-attention conjunta, nao "atencao cruzada", alinhado a correcao
  ja feita no artigo)
</commit_message>
<xml_diff>
--- a/docs/Apresentacao_AgroSele.pptx
+++ b/docs/Apresentacao_AgroSele.pptx
@@ -16,6 +16,7 @@
     <p:sldId id="264" r:id="rId15"/>
     <p:sldId id="265" r:id="rId16"/>
     <p:sldId id="266" r:id="rId17"/>
+    <p:sldId id="267" r:id="rId18"/>
   </p:sldIdLst>
   <p:sldSz cx="12191695" cy="6858000" type="screen4x3"/>
   <p:notesSz cx="6858000" cy="9144000"/>
@@ -3484,7 +3485,7 @@
               </a:defRPr>
             </a:pPr>
             <a:r>
-              <a:t>Limitações</a:t>
+              <a:t>Demonstração ao Vivo</a:t>
             </a:r>
           </a:p>
         </p:txBody>
@@ -3522,7 +3523,52 @@
               </a:defRPr>
             </a:pPr>
             <a:r>
-              <a:t>•  Truncamento de texto em 256 tokens (128 nas variantes com fine-tuning/Cross-Encoder) descarta informação de cauda em respostas longas</a:t>
+              <a:t>•  Uma pergunta real do conjunto de teste (nunca vista em treino) ranqueada por 3 métodos, ao vivo, sem retreinar nada:</a:t>
+            </a:r>
+          </a:p>
+          <a:p>
+            <a:pPr>
+              <a:spcAft>
+                <a:spcPts val="600"/>
+              </a:spcAft>
+              <a:defRPr sz="1600">
+                <a:solidFill>
+                  <a:srgbClr val="4A4A4A"/>
+                </a:solidFill>
+              </a:defRPr>
+            </a:pPr>
+            <a:r>
+              <a:t>     -  1. TF-IDF — léxico puro</a:t>
+            </a:r>
+          </a:p>
+          <a:p>
+            <a:pPr>
+              <a:spcAft>
+                <a:spcPts val="600"/>
+              </a:spcAft>
+              <a:defRPr sz="1600">
+                <a:solidFill>
+                  <a:srgbClr val="4A4A4A"/>
+                </a:solidFill>
+              </a:defRPr>
+            </a:pPr>
+            <a:r>
+              <a:t>     -  2. Cosseno sobre BERTimbau congelado — neural, sem treino</a:t>
+            </a:r>
+          </a:p>
+          <a:p>
+            <a:pPr>
+              <a:spcAft>
+                <a:spcPts val="600"/>
+              </a:spcAft>
+              <a:defRPr sz="1600">
+                <a:solidFill>
+                  <a:srgbClr val="4A4A4A"/>
+                </a:solidFill>
+              </a:defRPr>
+            </a:pPr>
+            <a:r>
+              <a:t>     -  3. Cross-Encoder treinado — self-attention conjunta sobre o par</a:t>
             </a:r>
           </a:p>
           <a:p>
@@ -3537,7 +3583,7 @@
               </a:defRPr>
             </a:pPr>
             <a:r>
-              <a:t>•  Amostragem de negativos majoritariamente aleatória (hard negative mining testado, sem ganho estatístico)</a:t>
+              <a:t>•  Notebook: docs/demo_sala_aula.ipynb (caches e checkpoints já prontos, cada célula roda em segundos)</a:t>
             </a:r>
           </a:p>
           <a:p>
@@ -3552,37 +3598,7 @@
               </a:defRPr>
             </a:pPr>
             <a:r>
-              <a:t>•  Backbone congelado nas variantes híbrida e Cross-Encoder — não explora combinar arquitetura + fine-tuning simultaneamente</a:t>
-            </a:r>
-          </a:p>
-          <a:p>
-            <a:pPr>
-              <a:spcAft>
-                <a:spcPts val="1400"/>
-              </a:spcAft>
-              <a:defRPr sz="2000">
-                <a:solidFill>
-                  <a:srgbClr val="222222"/>
-                </a:solidFill>
-              </a:defRPr>
-            </a:pPr>
-            <a:r>
-              <a:t>•  Sem comparação direta com uma API comercial de LLM (decisão metodológica: custo, latência, privacidade, determinismo)</a:t>
-            </a:r>
-          </a:p>
-          <a:p>
-            <a:pPr>
-              <a:spcAft>
-                <a:spcPts val="1400"/>
-              </a:spcAft>
-              <a:defRPr sz="2000">
-                <a:solidFill>
-                  <a:srgbClr val="222222"/>
-                </a:solidFill>
-              </a:defRPr>
-            </a:pPr>
-            <a:r>
-              <a:t>•  Modelo ainda erra sistematicamente diante de candidatas lexicalmente densas, mesmo quando fora do subtema exato</a:t>
+              <a:t>•  A turma escolhe o número da pergunta (0 a 299) — resultado é genuinamente ao vivo, não ensaiado</a:t>
             </a:r>
           </a:p>
         </p:txBody>
@@ -3596,6 +3612,208 @@
 </file>
 
 <file path=ppt/slides/slide11.xml><?xml version="1.0" encoding="utf-8"?>
+<p:sld xmlns:a="http://schemas.openxmlformats.org/drawingml/2006/main" xmlns:p="http://schemas.openxmlformats.org/presentationml/2006/main" xmlns:r="http://schemas.openxmlformats.org/officeDocument/2006/relationships">
+  <p:cSld>
+    <p:bg>
+      <p:bgPr>
+        <a:solidFill>
+          <a:srgbClr val="FFFFFF"/>
+        </a:solidFill>
+        <a:effectLst/>
+      </p:bgPr>
+    </p:bg>
+    <p:spTree>
+      <p:nvGrpSpPr>
+        <p:cNvPr id="1" name=""/>
+        <p:cNvGrpSpPr/>
+        <p:nvPr/>
+      </p:nvGrpSpPr>
+      <p:grpSpPr/>
+      <p:sp>
+        <p:nvSpPr>
+          <p:cNvPr id="2" name="Rectangle 1"/>
+          <p:cNvSpPr/>
+          <p:nvPr/>
+        </p:nvSpPr>
+        <p:spPr>
+          <a:xfrm>
+            <a:off x="0" y="0"/>
+            <a:ext cx="12191695" cy="137160"/>
+          </a:xfrm>
+          <a:prstGeom prst="rect">
+            <a:avLst/>
+          </a:prstGeom>
+          <a:solidFill>
+            <a:srgbClr val="2E7D32"/>
+          </a:solidFill>
+          <a:ln>
+            <a:noFill/>
+          </a:ln>
+        </p:spPr>
+        <p:style>
+          <a:lnRef idx="1">
+            <a:schemeClr val="accent1"/>
+          </a:lnRef>
+          <a:fillRef idx="3">
+            <a:schemeClr val="accent1"/>
+          </a:fillRef>
+          <a:effectRef idx="2">
+            <a:schemeClr val="accent1"/>
+          </a:effectRef>
+          <a:fontRef idx="minor">
+            <a:schemeClr val="lt1"/>
+          </a:fontRef>
+        </p:style>
+        <p:txBody>
+          <a:bodyPr rtlCol="0" anchor="ctr"/>
+          <a:lstStyle/>
+          <a:p>
+            <a:pPr algn="ctr"/>
+          </a:p>
+        </p:txBody>
+      </p:sp>
+      <p:sp>
+        <p:nvSpPr>
+          <p:cNvPr id="3" name="TextBox 2"/>
+          <p:cNvSpPr txBox="1"/>
+          <p:nvPr/>
+        </p:nvSpPr>
+        <p:spPr>
+          <a:xfrm>
+            <a:off x="548640" y="365760"/>
+            <a:ext cx="11064240" cy="914400"/>
+          </a:xfrm>
+          <a:prstGeom prst="rect">
+            <a:avLst/>
+          </a:prstGeom>
+          <a:noFill/>
+        </p:spPr>
+        <p:txBody>
+          <a:bodyPr wrap="square">
+            <a:spAutoFit/>
+          </a:bodyPr>
+          <a:lstStyle/>
+          <a:p>
+            <a:pPr>
+              <a:defRPr sz="3200" b="1">
+                <a:solidFill>
+                  <a:srgbClr val="1B3A5C"/>
+                </a:solidFill>
+              </a:defRPr>
+            </a:pPr>
+            <a:r>
+              <a:t>Limitações</a:t>
+            </a:r>
+          </a:p>
+        </p:txBody>
+      </p:sp>
+      <p:sp>
+        <p:nvSpPr>
+          <p:cNvPr id="4" name="TextBox 3"/>
+          <p:cNvSpPr txBox="1"/>
+          <p:nvPr/>
+        </p:nvSpPr>
+        <p:spPr>
+          <a:xfrm>
+            <a:off x="731520" y="1463040"/>
+            <a:ext cx="10698480" cy="4754880"/>
+          </a:xfrm>
+          <a:prstGeom prst="rect">
+            <a:avLst/>
+          </a:prstGeom>
+          <a:noFill/>
+        </p:spPr>
+        <p:txBody>
+          <a:bodyPr wrap="square">
+            <a:spAutoFit/>
+          </a:bodyPr>
+          <a:lstStyle/>
+          <a:p>
+            <a:pPr>
+              <a:spcAft>
+                <a:spcPts val="1400"/>
+              </a:spcAft>
+              <a:defRPr sz="2000">
+                <a:solidFill>
+                  <a:srgbClr val="222222"/>
+                </a:solidFill>
+              </a:defRPr>
+            </a:pPr>
+            <a:r>
+              <a:t>•  Truncamento de texto em 256 tokens (128 nas variantes com fine-tuning/Cross-Encoder) descarta informação de cauda em respostas longas</a:t>
+            </a:r>
+          </a:p>
+          <a:p>
+            <a:pPr>
+              <a:spcAft>
+                <a:spcPts val="1400"/>
+              </a:spcAft>
+              <a:defRPr sz="2000">
+                <a:solidFill>
+                  <a:srgbClr val="222222"/>
+                </a:solidFill>
+              </a:defRPr>
+            </a:pPr>
+            <a:r>
+              <a:t>•  Amostragem de negativos majoritariamente aleatória (hard negative mining testado, sem ganho estatístico)</a:t>
+            </a:r>
+          </a:p>
+          <a:p>
+            <a:pPr>
+              <a:spcAft>
+                <a:spcPts val="1400"/>
+              </a:spcAft>
+              <a:defRPr sz="2000">
+                <a:solidFill>
+                  <a:srgbClr val="222222"/>
+                </a:solidFill>
+              </a:defRPr>
+            </a:pPr>
+            <a:r>
+              <a:t>•  Backbone congelado nas variantes híbrida e Cross-Encoder — não explora combinar arquitetura + fine-tuning simultaneamente</a:t>
+            </a:r>
+          </a:p>
+          <a:p>
+            <a:pPr>
+              <a:spcAft>
+                <a:spcPts val="1400"/>
+              </a:spcAft>
+              <a:defRPr sz="2000">
+                <a:solidFill>
+                  <a:srgbClr val="222222"/>
+                </a:solidFill>
+              </a:defRPr>
+            </a:pPr>
+            <a:r>
+              <a:t>•  Sem comparação direta com uma API comercial de LLM (decisão metodológica: custo, latência, privacidade, determinismo)</a:t>
+            </a:r>
+          </a:p>
+          <a:p>
+            <a:pPr>
+              <a:spcAft>
+                <a:spcPts val="1400"/>
+              </a:spcAft>
+              <a:defRPr sz="2000">
+                <a:solidFill>
+                  <a:srgbClr val="222222"/>
+                </a:solidFill>
+              </a:defRPr>
+            </a:pPr>
+            <a:r>
+              <a:t>•  Modelo ainda erra sistematicamente diante de candidatas lexicalmente densas, mesmo quando fora do subtema exato</a:t>
+            </a:r>
+          </a:p>
+        </p:txBody>
+      </p:sp>
+    </p:spTree>
+  </p:cSld>
+  <p:clrMapOvr>
+    <a:masterClrMapping/>
+  </p:clrMapOvr>
+</p:sld>
+</file>
+
+<file path=ppt/slides/slide12.xml><?xml version="1.0" encoding="utf-8"?>
 <p:sld xmlns:a="http://schemas.openxmlformats.org/drawingml/2006/main" xmlns:p="http://schemas.openxmlformats.org/presentationml/2006/main" xmlns:r="http://schemas.openxmlformats.org/officeDocument/2006/relationships">
   <p:cSld>
     <p:bg>
@@ -4565,7 +4783,7 @@
               </a:defRPr>
             </a:pPr>
             <a:r>
-              <a:t>•  3. Cross-Encoder — atenção cruzada entre pergunta e candidata, congelado</a:t>
+              <a:t>•  3. Cross-Encoder — self-attention conjunta sobre o par pergunta+candidata, congelado</a:t>
             </a:r>
           </a:p>
           <a:p>

</xml_diff>